<commit_message>
added slide for code review findings
</commit_message>
<xml_diff>
--- a/Day2/code_review/code_review.pptx
+++ b/Day2/code_review/code_review.pptx
@@ -7,6 +7,7 @@
   <p:sldIdLst>
     <p:sldId id="257" r:id="rId3"/>
     <p:sldId id="258" r:id="rId4"/>
+    <p:sldId id="259" r:id="rId5"/>
   </p:sldIdLst>
   <p:sldSz cx="12192000" cy="6858000"/>
   <p:notesSz cx="6858000" cy="9144000"/>
@@ -3092,7 +3093,7 @@
           <a:p>
             <a:r>
               <a:rPr lang="en-US"/>
-              <a:t>Code Review</a:t>
+              <a:t>Coding Assignment</a:t>
             </a:r>
             <a:endParaRPr lang="en-US"/>
           </a:p>
@@ -3117,14 +3118,15 @@
           <a:p>
             <a:r>
               <a:rPr lang="en-US"/>
-              <a:t>Write a simple function that either adds or multiplies two numbers</a:t>
-            </a:r>
-            <a:endParaRPr lang="en-US"/>
-          </a:p>
-          <a:p>
+              <a:t>Write a simple program that either adds or multiplies two numbers</a:t>
+            </a:r>
+            <a:endParaRPr lang="en-US"/>
+          </a:p>
+          <a:p>
+            <a:pPr lvl="0"/>
             <a:r>
               <a:rPr lang="en-US"/>
-              <a:t>Name the function:</a:t>
+              <a:t>The program accepts three arguments:</a:t>
             </a:r>
             <a:endParaRPr lang="en-US"/>
           </a:p>
@@ -3132,15 +3134,15 @@
             <a:pPr lvl="1"/>
             <a:r>
               <a:rPr lang="en-US"/>
-              <a:t>add_or_multiply()</a:t>
-            </a:r>
-            <a:endParaRPr lang="en-US"/>
-          </a:p>
-          <a:p>
-            <a:pPr lvl="0"/>
+              <a:t>Input 1 - the first number</a:t>
+            </a:r>
+            <a:endParaRPr lang="en-US"/>
+          </a:p>
+          <a:p>
+            <a:pPr lvl="1"/>
             <a:r>
               <a:rPr lang="en-US"/>
-              <a:t>The function accepts three arguments:</a:t>
+              <a:t>Input 2 - the second number</a:t>
             </a:r>
             <a:endParaRPr lang="en-US"/>
           </a:p>
@@ -3148,23 +3150,7 @@
             <a:pPr lvl="1"/>
             <a:r>
               <a:rPr lang="en-US"/>
-              <a:t>Arg 1 - a: the first number</a:t>
-            </a:r>
-            <a:endParaRPr lang="en-US"/>
-          </a:p>
-          <a:p>
-            <a:pPr lvl="1"/>
-            <a:r>
-              <a:rPr lang="en-US"/>
-              <a:t>Arg 2 - b: the second number</a:t>
-            </a:r>
-            <a:endParaRPr lang="en-US"/>
-          </a:p>
-          <a:p>
-            <a:pPr lvl="1"/>
-            <a:r>
-              <a:rPr lang="en-US"/>
-              <a:t>Arg 3 - operation: A string that takes one of two possible values - ‘+’ or ‘x’</a:t>
+              <a:t>Input 3 - operation: A string that takes one of two possible values - ‘+’ or ‘x’</a:t>
             </a:r>
             <a:endParaRPr lang="en-US"/>
           </a:p>
@@ -3229,7 +3215,7 @@
         </p:nvGraphicFramePr>
         <p:xfrm>
           <a:off x="608400" y="1490400"/>
-          <a:ext cx="10968990" cy="2286000"/>
+          <a:ext cx="10968990" cy="2926080"/>
         </p:xfrm>
         <a:graphic>
           <a:graphicData uri="http://schemas.openxmlformats.org/drawingml/2006/table">
@@ -3238,8 +3224,10 @@
                 <a:tableStyleId>{5C22544A-7EE6-4342-B048-85BDC9FD1C3A}</a:tableStyleId>
               </a:tblPr>
               <a:tblGrid>
-                <a:gridCol w="5484495"/>
-                <a:gridCol w="5484495"/>
+                <a:gridCol w="2742248"/>
+                <a:gridCol w="2742247"/>
+                <a:gridCol w="2742248"/>
+                <a:gridCol w="2742247"/>
               </a:tblGrid>
               <a:tr h="381000">
                 <a:tc>
@@ -3251,7 +3239,39 @@
                       </a:pPr>
                       <a:r>
                         <a:rPr lang="en-US"/>
-                        <a:t>Function Call</a:t>
+                        <a:t>Input 1</a:t>
+                      </a:r>
+                      <a:endParaRPr lang="en-US"/>
+                    </a:p>
+                  </a:txBody>
+                  <a:tcPr/>
+                </a:tc>
+                <a:tc>
+                  <a:txBody>
+                    <a:bodyPr/>
+                    <a:p>
+                      <a:pPr>
+                        <a:buNone/>
+                      </a:pPr>
+                      <a:r>
+                        <a:rPr lang="en-US"/>
+                        <a:t>Input 2</a:t>
+                      </a:r>
+                      <a:endParaRPr lang="en-US"/>
+                    </a:p>
+                  </a:txBody>
+                  <a:tcPr/>
+                </a:tc>
+                <a:tc>
+                  <a:txBody>
+                    <a:bodyPr/>
+                    <a:p>
+                      <a:pPr>
+                        <a:buNone/>
+                      </a:pPr>
+                      <a:r>
+                        <a:rPr lang="en-US"/>
+                        <a:t>Input 3</a:t>
                       </a:r>
                       <a:endParaRPr lang="en-US"/>
                     </a:p>
@@ -3287,7 +3307,39 @@
                         <a:rPr lang="en-US" sz="1800">
                           <a:sym typeface="+mn-ea"/>
                         </a:rPr>
-                        <a:t>add_or_multiply(1, 2, ‘+’)</a:t>
+                        <a:t>1</a:t>
+                      </a:r>
+                      <a:endParaRPr lang="en-US"/>
+                    </a:p>
+                  </a:txBody>
+                  <a:tcPr/>
+                </a:tc>
+                <a:tc>
+                  <a:txBody>
+                    <a:bodyPr/>
+                    <a:p>
+                      <a:pPr>
+                        <a:buNone/>
+                      </a:pPr>
+                      <a:r>
+                        <a:rPr lang="en-US"/>
+                        <a:t>2</a:t>
+                      </a:r>
+                      <a:endParaRPr lang="en-US"/>
+                    </a:p>
+                  </a:txBody>
+                  <a:tcPr/>
+                </a:tc>
+                <a:tc>
+                  <a:txBody>
+                    <a:bodyPr/>
+                    <a:p>
+                      <a:pPr>
+                        <a:buNone/>
+                      </a:pPr>
+                      <a:r>
+                        <a:rPr lang="en-US"/>
+                        <a:t>‘+’</a:t>
                       </a:r>
                       <a:endParaRPr lang="en-US"/>
                     </a:p>
@@ -3323,7 +3375,39 @@
                         <a:rPr lang="en-US" sz="1800">
                           <a:sym typeface="+mn-ea"/>
                         </a:rPr>
-                        <a:t>add_or_multiply(1, 2, ‘x’)</a:t>
+                        <a:t>1</a:t>
+                      </a:r>
+                      <a:endParaRPr lang="en-US"/>
+                    </a:p>
+                  </a:txBody>
+                  <a:tcPr/>
+                </a:tc>
+                <a:tc>
+                  <a:txBody>
+                    <a:bodyPr/>
+                    <a:p>
+                      <a:pPr>
+                        <a:buNone/>
+                      </a:pPr>
+                      <a:r>
+                        <a:rPr lang="en-US"/>
+                        <a:t>2</a:t>
+                      </a:r>
+                      <a:endParaRPr lang="en-US"/>
+                    </a:p>
+                  </a:txBody>
+                  <a:tcPr/>
+                </a:tc>
+                <a:tc>
+                  <a:txBody>
+                    <a:bodyPr/>
+                    <a:p>
+                      <a:pPr>
+                        <a:buNone/>
+                      </a:pPr>
+                      <a:r>
+                        <a:rPr lang="en-US"/>
+                        <a:t>‘x’</a:t>
                       </a:r>
                       <a:endParaRPr lang="en-US"/>
                     </a:p>
@@ -3357,7 +3441,39 @@
                       </a:pPr>
                       <a:r>
                         <a:rPr lang="en-US" altLang="en-US"/>
-                        <a:t>add_or_multiply(1, 2, '/')</a:t>
+                        <a:t>1</a:t>
+                      </a:r>
+                      <a:endParaRPr lang="en-US" altLang="en-US"/>
+                    </a:p>
+                  </a:txBody>
+                  <a:tcPr/>
+                </a:tc>
+                <a:tc>
+                  <a:txBody>
+                    <a:bodyPr/>
+                    <a:p>
+                      <a:pPr>
+                        <a:buNone/>
+                      </a:pPr>
+                      <a:r>
+                        <a:rPr lang="en-US" altLang="en-US"/>
+                        <a:t>2</a:t>
+                      </a:r>
+                      <a:endParaRPr lang="en-US" altLang="en-US"/>
+                    </a:p>
+                  </a:txBody>
+                  <a:tcPr/>
+                </a:tc>
+                <a:tc>
+                  <a:txBody>
+                    <a:bodyPr/>
+                    <a:p>
+                      <a:pPr>
+                        <a:buNone/>
+                      </a:pPr>
+                      <a:r>
+                        <a:rPr lang="en-US" altLang="en-US"/>
+                        <a:t>‘/’</a:t>
                       </a:r>
                       <a:endParaRPr lang="en-US" altLang="en-US"/>
                     </a:p>
@@ -3393,7 +3509,105 @@
                         <a:rPr lang="en-US" altLang="en-US" sz="1800">
                           <a:sym typeface="+mn-ea"/>
                         </a:rPr>
-                        <a:t>add_or_multiply(1, ‘two’, '+')</a:t>
+                        <a:t>1</a:t>
+                      </a:r>
+                      <a:endParaRPr lang="en-US" altLang="en-US"/>
+                    </a:p>
+                  </a:txBody>
+                  <a:tcPr/>
+                </a:tc>
+                <a:tc>
+                  <a:txBody>
+                    <a:bodyPr/>
+                    <a:p>
+                      <a:pPr>
+                        <a:buNone/>
+                      </a:pPr>
+                      <a:r>
+                        <a:rPr lang="en-US" altLang="en-US"/>
+                        <a:t>‘two’</a:t>
+                      </a:r>
+                      <a:endParaRPr lang="en-US" altLang="en-US"/>
+                    </a:p>
+                  </a:txBody>
+                  <a:tcPr/>
+                </a:tc>
+                <a:tc>
+                  <a:txBody>
+                    <a:bodyPr/>
+                    <a:p>
+                      <a:pPr>
+                        <a:buNone/>
+                      </a:pPr>
+                      <a:r>
+                        <a:rPr lang="en-US" altLang="en-US"/>
+                        <a:t>‘+’</a:t>
+                      </a:r>
+                      <a:endParaRPr lang="en-US" altLang="en-US"/>
+                    </a:p>
+                  </a:txBody>
+                  <a:tcPr/>
+                </a:tc>
+                <a:tc>
+                  <a:txBody>
+                    <a:bodyPr/>
+                    <a:p>
+                      <a:pPr>
+                        <a:buNone/>
+                      </a:pPr>
+                      <a:r>
+                        <a:rPr lang="en-US"/>
+                        <a:t>Should Fail</a:t>
+                      </a:r>
+                      <a:endParaRPr lang="en-US"/>
+                    </a:p>
+                  </a:txBody>
+                  <a:tcPr/>
+                </a:tc>
+              </a:tr>
+              <a:tr h="381000">
+                <a:tc>
+                  <a:txBody>
+                    <a:bodyPr/>
+                    <a:p>
+                      <a:pPr>
+                        <a:buNone/>
+                      </a:pPr>
+                      <a:r>
+                        <a:rPr lang="en-US" altLang="en-US"/>
+                        <a:t>1</a:t>
+                      </a:r>
+                      <a:endParaRPr lang="en-US" altLang="en-US"/>
+                    </a:p>
+                  </a:txBody>
+                  <a:tcPr/>
+                </a:tc>
+                <a:tc>
+                  <a:txBody>
+                    <a:bodyPr/>
+                    <a:p>
+                      <a:pPr>
+                        <a:buNone/>
+                      </a:pPr>
+                      <a:r>
+                        <a:rPr lang="en-US" altLang="en-US"/>
+                        <a:t>‘2’</a:t>
+                      </a:r>
+                      <a:endParaRPr lang="en-US" altLang="en-US"/>
+                    </a:p>
+                  </a:txBody>
+                  <a:tcPr/>
+                </a:tc>
+                <a:tc>
+                  <a:txBody>
+                    <a:bodyPr/>
+                    <a:p>
+                      <a:pPr>
+                        <a:buNone/>
+                      </a:pPr>
+                      <a:r>
+                        <a:rPr lang="en-US" altLang="en-US"/>
+                        <a:t>‘+’</a:t>
                       </a:r>
                       <a:endParaRPr lang="en-US" altLang="en-US"/>
                     </a:p>
@@ -3429,7 +3643,39 @@
                         <a:rPr lang="en-US" altLang="en-US" sz="1800">
                           <a:sym typeface="+mn-ea"/>
                         </a:rPr>
-                        <a:t>add_or_multiply(1, 2, 1234)</a:t>
+                        <a:t>1</a:t>
+                      </a:r>
+                      <a:endParaRPr lang="en-US" altLang="en-US"/>
+                    </a:p>
+                  </a:txBody>
+                  <a:tcPr/>
+                </a:tc>
+                <a:tc>
+                  <a:txBody>
+                    <a:bodyPr/>
+                    <a:p>
+                      <a:pPr>
+                        <a:buNone/>
+                      </a:pPr>
+                      <a:r>
+                        <a:rPr lang="en-US" altLang="en-US"/>
+                        <a:t>2</a:t>
+                      </a:r>
+                      <a:endParaRPr lang="en-US" altLang="en-US"/>
+                    </a:p>
+                  </a:txBody>
+                  <a:tcPr/>
+                </a:tc>
+                <a:tc>
+                  <a:txBody>
+                    <a:bodyPr/>
+                    <a:p>
+                      <a:pPr>
+                        <a:buNone/>
+                      </a:pPr>
+                      <a:r>
+                        <a:rPr lang="en-US" altLang="en-US"/>
+                        <a:t>3</a:t>
                       </a:r>
                       <a:endParaRPr lang="en-US" altLang="en-US"/>
                     </a:p>
@@ -3470,6 +3716,135 @@
 </p:sld>
 </file>
 
+<file path=ppt/slides/slide3.xml><?xml version="1.0" encoding="utf-8"?>
+<p:sld xmlns:a="http://schemas.openxmlformats.org/drawingml/2006/main" xmlns:r="http://schemas.openxmlformats.org/officeDocument/2006/relationships" xmlns:p="http://schemas.openxmlformats.org/presentationml/2006/main">
+  <p:cSld>
+    <p:spTree>
+      <p:nvGrpSpPr>
+        <p:cNvPr id="1" name=""/>
+        <p:cNvGrpSpPr/>
+        <p:nvPr/>
+      </p:nvGrpSpPr>
+      <p:grpSpPr/>
+      <p:sp>
+        <p:nvSpPr>
+          <p:cNvPr id="2" name="Title 1"/>
+          <p:cNvSpPr>
+            <a:spLocks noGrp="1"/>
+          </p:cNvSpPr>
+          <p:nvPr>
+            <p:ph type="title"/>
+            <p:custDataLst>
+              <p:tags r:id="rId1"/>
+            </p:custDataLst>
+          </p:nvPr>
+        </p:nvSpPr>
+        <p:spPr/>
+        <p:txBody>
+          <a:bodyPr/>
+          <a:p>
+            <a:r>
+              <a:rPr lang="en-US"/>
+              <a:t>Code Review</a:t>
+            </a:r>
+            <a:endParaRPr lang="en-US"/>
+          </a:p>
+        </p:txBody>
+      </p:sp>
+      <p:sp>
+        <p:nvSpPr>
+          <p:cNvPr id="3" name="Content Placeholder 2"/>
+          <p:cNvSpPr>
+            <a:spLocks noGrp="1"/>
+          </p:cNvSpPr>
+          <p:nvPr>
+            <p:ph idx="1"/>
+            <p:custDataLst>
+              <p:tags r:id="rId2"/>
+            </p:custDataLst>
+          </p:nvPr>
+        </p:nvSpPr>
+        <p:spPr/>
+        <p:txBody>
+          <a:bodyPr/>
+          <a:p>
+            <a:r>
+              <a:rPr lang="en-US"/>
+              <a:t>Modularize your code into fuctions</a:t>
+            </a:r>
+            <a:endParaRPr lang="en-US"/>
+          </a:p>
+          <a:p>
+            <a:r>
+              <a:rPr lang="en-US"/>
+              <a:t>Create a ‘main’ entry point to invoke your program</a:t>
+            </a:r>
+            <a:endParaRPr lang="en-US"/>
+          </a:p>
+          <a:p>
+            <a:r>
+              <a:rPr lang="en-US"/>
+              <a:t>Avoid accepting ‘inputs’ from the terminal</a:t>
+            </a:r>
+            <a:endParaRPr lang="en-US"/>
+          </a:p>
+          <a:p>
+            <a:r>
+              <a:rPr lang="en-US"/>
+              <a:t>Use intuitive naming conventions</a:t>
+            </a:r>
+            <a:endParaRPr lang="en-US"/>
+          </a:p>
+          <a:p>
+            <a:r>
+              <a:rPr lang="en-US"/>
+              <a:t>Code must look pretty</a:t>
+            </a:r>
+            <a:endParaRPr lang="en-US"/>
+          </a:p>
+          <a:p>
+            <a:r>
+              <a:rPr lang="en-US"/>
+              <a:t>Perform validation of inputs before business logic</a:t>
+            </a:r>
+            <a:endParaRPr lang="en-US"/>
+          </a:p>
+          <a:p>
+            <a:r>
+              <a:rPr lang="en-US"/>
+              <a:t>Fail fast by raising exceptions</a:t>
+            </a:r>
+            <a:endParaRPr lang="en-US"/>
+          </a:p>
+          <a:p>
+            <a:r>
+              <a:rPr lang="en-US"/>
+              <a:t>Return results instead of printing them</a:t>
+            </a:r>
+            <a:endParaRPr lang="en-US"/>
+          </a:p>
+          <a:p>
+            <a:r>
+              <a:rPr lang="en-US">
+                <a:sym typeface="+mn-ea"/>
+              </a:rPr>
+              <a:t>Create test cases</a:t>
+            </a:r>
+            <a:endParaRPr lang="en-US"/>
+          </a:p>
+        </p:txBody>
+      </p:sp>
+    </p:spTree>
+    <p:custDataLst>
+      <p:tags r:id="rId3"/>
+    </p:custDataLst>
+  </p:cSld>
+  <p:clrMapOvr>
+    <a:masterClrMapping/>
+  </p:clrMapOvr>
+</p:sld>
+</file>
+
 <file path=ppt/tags/tag1.xml><?xml version="1.0" encoding="utf-8"?>
 <p:tagLst xmlns:p="http://schemas.openxmlformats.org/presentationml/2006/main">
   <p:tag name="KSO_WM_UNIT_HIGHLIGHT" val="0"/>
@@ -4310,6 +4685,19 @@
 </p:tagLst>
 </file>
 
+<file path=ppt/tags/tag69.xml><?xml version="1.0" encoding="utf-8"?>
+<p:tagLst xmlns:p="http://schemas.openxmlformats.org/presentationml/2006/main">
+  <p:tag name="KSO_WM_UNIT_HIGHLIGHT" val="0"/>
+  <p:tag name="KSO_WM_UNIT_COMPATIBLE" val="0"/>
+  <p:tag name="KSO_WM_UNIT_DIAGRAM_ISNUMVISUAL" val="0"/>
+  <p:tag name="KSO_WM_UNIT_DIAGRAM_ISREFERUNIT" val="0"/>
+  <p:tag name="KSO_WM_UNIT_ID" val="_2**"/>
+  <p:tag name="KSO_WM_UNIT_LAYERLEVEL" val="1"/>
+  <p:tag name="KSO_WM_TAG_VERSION" val="1.0"/>
+  <p:tag name="KSO_WM_BEAUTIFY_FLAG" val="#wm#"/>
+</p:tagLst>
+</file>
+
 <file path=ppt/tags/tag7.xml><?xml version="1.0" encoding="utf-8"?>
 <p:tagLst xmlns:p="http://schemas.openxmlformats.org/presentationml/2006/main">
   <p:tag name="KSO_WM_UNIT_HIGHLIGHT" val="0"/>
@@ -4320,6 +4708,27 @@
   <p:tag name="KSO_WM_UNIT_LAYERLEVEL" val="1"/>
   <p:tag name="KSO_WM_TAG_VERSION" val="1.0"/>
   <p:tag name="KSO_WM_BEAUTIFY_FLAG" val="#wm#"/>
+</p:tagLst>
+</file>
+
+<file path=ppt/tags/tag70.xml><?xml version="1.0" encoding="utf-8"?>
+<p:tagLst xmlns:p="http://schemas.openxmlformats.org/presentationml/2006/main">
+  <p:tag name="KSO_WM_UNIT_HIGHLIGHT" val="0"/>
+  <p:tag name="KSO_WM_UNIT_COMPATIBLE" val="0"/>
+  <p:tag name="KSO_WM_UNIT_DIAGRAM_ISNUMVISUAL" val="0"/>
+  <p:tag name="KSO_WM_UNIT_DIAGRAM_ISREFERUNIT" val="0"/>
+  <p:tag name="KSO_WM_UNIT_ID" val="_2**"/>
+  <p:tag name="KSO_WM_UNIT_LAYERLEVEL" val="1"/>
+  <p:tag name="KSO_WM_TAG_VERSION" val="1.0"/>
+  <p:tag name="KSO_WM_BEAUTIFY_FLAG" val="#wm#"/>
+</p:tagLst>
+</file>
+
+<file path=ppt/tags/tag71.xml><?xml version="1.0" encoding="utf-8"?>
+<p:tagLst xmlns:p="http://schemas.openxmlformats.org/presentationml/2006/main">
+  <p:tag name="KSO_WM_BEAUTIFY_FLAG" val="#wm#"/>
+  <p:tag name="KSO_WM_TEMPLATE_CATEGORY" val="custom"/>
+  <p:tag name="KSO_WM_TEMPLATE_INDEX" val="20205081"/>
 </p:tagLst>
 </file>
 

</xml_diff>

<commit_message>
updated presentation for code review with animation
</commit_message>
<xml_diff>
--- a/Day2/code_review/code_review.pptx
+++ b/Day2/code_review/code_review.pptx
@@ -3215,7 +3215,7 @@
         </p:nvGraphicFramePr>
         <p:xfrm>
           <a:off x="608400" y="1490400"/>
-          <a:ext cx="10968990" cy="2926080"/>
+          <a:ext cx="10968990" cy="2667000"/>
         </p:xfrm>
         <a:graphic>
           <a:graphicData uri="http://schemas.openxmlformats.org/drawingml/2006/table">
@@ -3224,10 +3224,10 @@
                 <a:tableStyleId>{5C22544A-7EE6-4342-B048-85BDC9FD1C3A}</a:tableStyleId>
               </a:tblPr>
               <a:tblGrid>
-                <a:gridCol w="2742248"/>
-                <a:gridCol w="2742247"/>
-                <a:gridCol w="2742248"/>
-                <a:gridCol w="2742247"/>
+                <a:gridCol w="2209165"/>
+                <a:gridCol w="2379980"/>
+                <a:gridCol w="2152015"/>
+                <a:gridCol w="4227830"/>
               </a:tblGrid>
               <a:tr h="381000">
                 <a:tc>
@@ -3239,7 +3239,7 @@
                       </a:pPr>
                       <a:r>
                         <a:rPr lang="en-US"/>
-                        <a:t>Input 1</a:t>
+                        <a:t>Input 1 - Number</a:t>
                       </a:r>
                       <a:endParaRPr lang="en-US"/>
                     </a:p>
@@ -3255,7 +3255,7 @@
                       </a:pPr>
                       <a:r>
                         <a:rPr lang="en-US"/>
-                        <a:t>Input 2</a:t>
+                        <a:t>Input 2 - Number</a:t>
                       </a:r>
                       <a:endParaRPr lang="en-US"/>
                     </a:p>
@@ -3271,7 +3271,7 @@
                       </a:pPr>
                       <a:r>
                         <a:rPr lang="en-US"/>
-                        <a:t>Input 3</a:t>
+                        <a:t>Input 3 - Operator</a:t>
                       </a:r>
                       <a:endParaRPr lang="en-US"/>
                     </a:p>
@@ -3489,7 +3489,7 @@
                       </a:pPr>
                       <a:r>
                         <a:rPr lang="en-US"/>
-                        <a:t>Should Fail</a:t>
+                        <a:t>Should Fail - Bad Input 3</a:t>
                       </a:r>
                       <a:endParaRPr lang="en-US"/>
                     </a:p>
@@ -3557,7 +3557,7 @@
                       </a:pPr>
                       <a:r>
                         <a:rPr lang="en-US"/>
-                        <a:t>Should Fail</a:t>
+                        <a:t>Should Fail - Bad Input 2</a:t>
                       </a:r>
                       <a:endParaRPr lang="en-US"/>
                     </a:p>
@@ -3575,7 +3575,7 @@
                       </a:pPr>
                       <a:r>
                         <a:rPr lang="en-US" altLang="en-US"/>
-                        <a:t>1</a:t>
+                        <a:t>‘1’</a:t>
                       </a:r>
                       <a:endParaRPr lang="en-US" altLang="en-US"/>
                     </a:p>
@@ -3591,7 +3591,7 @@
                       </a:pPr>
                       <a:r>
                         <a:rPr lang="en-US" altLang="en-US"/>
-                        <a:t>‘2’</a:t>
+                        <a:t>2</a:t>
                       </a:r>
                       <a:endParaRPr lang="en-US" altLang="en-US"/>
                     </a:p>
@@ -3623,7 +3623,7 @@
                       </a:pPr>
                       <a:r>
                         <a:rPr lang="en-US"/>
-                        <a:t>Should Fail</a:t>
+                        <a:t>Should Fail - Bad Input 1</a:t>
                       </a:r>
                       <a:endParaRPr lang="en-US"/>
                     </a:p>
@@ -3693,7 +3693,7 @@
                         <a:rPr lang="en-US" sz="1800">
                           <a:sym typeface="+mn-ea"/>
                         </a:rPr>
-                        <a:t>Should Fail</a:t>
+                        <a:t>Should Fail - Bad Input 3</a:t>
                       </a:r>
                       <a:endParaRPr lang="en-US"/>
                     </a:p>
@@ -3764,73 +3764,82 @@
             </p:custDataLst>
           </p:nvPr>
         </p:nvSpPr>
-        <p:spPr/>
-        <p:txBody>
-          <a:bodyPr/>
-          <a:p>
-            <a:r>
-              <a:rPr lang="en-US"/>
+        <p:spPr>
+          <a:xfrm>
+            <a:off x="608330" y="1242695"/>
+            <a:ext cx="10968990" cy="5482590"/>
+          </a:xfrm>
+        </p:spPr>
+        <p:txBody>
+          <a:bodyPr>
+            <a:noAutofit/>
+          </a:bodyPr>
+          <a:p>
+            <a:r>
+              <a:rPr lang="en-US" sz="2400"/>
               <a:t>Modularize your code into fuctions</a:t>
             </a:r>
-            <a:endParaRPr lang="en-US"/>
-          </a:p>
-          <a:p>
-            <a:r>
-              <a:rPr lang="en-US"/>
+            <a:endParaRPr lang="en-US" sz="2400"/>
+          </a:p>
+          <a:p>
+            <a:r>
+              <a:rPr lang="en-US" sz="2400"/>
               <a:t>Create a ‘main’ entry point to invoke your program</a:t>
             </a:r>
-            <a:endParaRPr lang="en-US"/>
-          </a:p>
-          <a:p>
-            <a:r>
-              <a:rPr lang="en-US"/>
+            <a:endParaRPr lang="en-US" sz="2400"/>
+          </a:p>
+          <a:p>
+            <a:r>
+              <a:rPr lang="en-US" sz="2400"/>
               <a:t>Avoid accepting ‘inputs’ from the terminal</a:t>
             </a:r>
-            <a:endParaRPr lang="en-US"/>
-          </a:p>
-          <a:p>
-            <a:r>
-              <a:rPr lang="en-US"/>
+            <a:endParaRPr lang="en-US" sz="2400"/>
+          </a:p>
+          <a:p>
+            <a:r>
+              <a:rPr lang="en-US" sz="2400"/>
               <a:t>Use intuitive naming conventions</a:t>
             </a:r>
-            <a:endParaRPr lang="en-US"/>
-          </a:p>
-          <a:p>
-            <a:r>
-              <a:rPr lang="en-US"/>
+            <a:endParaRPr lang="en-US" sz="2400"/>
+          </a:p>
+          <a:p>
+            <a:r>
+              <a:rPr lang="en-US" sz="2400"/>
               <a:t>Code must look pretty</a:t>
             </a:r>
-            <a:endParaRPr lang="en-US"/>
-          </a:p>
-          <a:p>
-            <a:r>
-              <a:rPr lang="en-US"/>
+            <a:endParaRPr lang="en-US" sz="2400"/>
+          </a:p>
+          <a:p>
+            <a:r>
+              <a:rPr lang="en-US" sz="2400"/>
               <a:t>Perform validation of inputs before business logic</a:t>
             </a:r>
-            <a:endParaRPr lang="en-US"/>
-          </a:p>
-          <a:p>
-            <a:r>
-              <a:rPr lang="en-US"/>
+            <a:endParaRPr lang="en-US" sz="2400"/>
+          </a:p>
+          <a:p>
+            <a:r>
+              <a:rPr lang="en-US" sz="2400"/>
               <a:t>Fail fast by raising exceptions</a:t>
             </a:r>
-            <a:endParaRPr lang="en-US"/>
-          </a:p>
-          <a:p>
-            <a:r>
-              <a:rPr lang="en-US"/>
+            <a:endParaRPr lang="en-US" sz="2400"/>
+          </a:p>
+          <a:p>
+            <a:r>
+              <a:rPr lang="en-US" sz="2400"/>
               <a:t>Return results instead of printing them</a:t>
             </a:r>
-            <a:endParaRPr lang="en-US"/>
-          </a:p>
-          <a:p>
-            <a:r>
-              <a:rPr lang="en-US">
+            <a:endParaRPr lang="en-US" sz="2400"/>
+          </a:p>
+          <a:p>
+            <a:r>
+              <a:rPr lang="en-US" sz="2400">
                 <a:sym typeface="+mn-ea"/>
               </a:rPr>
               <a:t>Create test cases</a:t>
             </a:r>
-            <a:endParaRPr lang="en-US"/>
+            <a:endParaRPr lang="en-US" sz="2400">
+              <a:sym typeface="+mn-ea"/>
+            </a:endParaRPr>
           </a:p>
         </p:txBody>
       </p:sp>
@@ -3842,6 +3851,481 @@
   <p:clrMapOvr>
     <a:masterClrMapping/>
   </p:clrMapOvr>
+  <p:timing>
+    <p:tnLst>
+      <p:par>
+        <p:cTn id="1" dur="indefinite" restart="never" nodeType="tmRoot">
+          <p:childTnLst>
+            <p:seq concurrent="1" nextAc="seek">
+              <p:cTn id="2" dur="indefinite" nodeType="mainSeq">
+                <p:childTnLst>
+                  <p:par>
+                    <p:cTn id="3" fill="hold">
+                      <p:stCondLst>
+                        <p:cond delay="indefinite"/>
+                      </p:stCondLst>
+                      <p:childTnLst>
+                        <p:par>
+                          <p:cTn id="4" fill="hold">
+                            <p:stCondLst>
+                              <p:cond delay="0"/>
+                            </p:stCondLst>
+                            <p:childTnLst>
+                              <p:par>
+                                <p:cTn id="5" presetID="1" presetClass="entr" presetSubtype="0" fill="hold" grpId="0" nodeType="clickEffect">
+                                  <p:stCondLst>
+                                    <p:cond delay="0"/>
+                                  </p:stCondLst>
+                                  <p:childTnLst>
+                                    <p:set>
+                                      <p:cBhvr>
+                                        <p:cTn id="6" dur="1" fill="hold">
+                                          <p:stCondLst>
+                                            <p:cond delay="0"/>
+                                          </p:stCondLst>
+                                        </p:cTn>
+                                        <p:tgtEl>
+                                          <p:spTgt spid="3">
+                                            <p:txEl>
+                                              <p:pRg st="0" end="0"/>
+                                            </p:txEl>
+                                          </p:spTgt>
+                                        </p:tgtEl>
+                                        <p:attrNameLst>
+                                          <p:attrName>style.visibility</p:attrName>
+                                        </p:attrNameLst>
+                                      </p:cBhvr>
+                                      <p:to>
+                                        <p:strVal val="visible"/>
+                                      </p:to>
+                                    </p:set>
+                                  </p:childTnLst>
+                                </p:cTn>
+                              </p:par>
+                            </p:childTnLst>
+                          </p:cTn>
+                        </p:par>
+                      </p:childTnLst>
+                    </p:cTn>
+                  </p:par>
+                  <p:par>
+                    <p:cTn id="7" fill="hold">
+                      <p:stCondLst>
+                        <p:cond delay="indefinite"/>
+                      </p:stCondLst>
+                      <p:childTnLst>
+                        <p:par>
+                          <p:cTn id="8" fill="hold">
+                            <p:stCondLst>
+                              <p:cond delay="0"/>
+                            </p:stCondLst>
+                            <p:childTnLst>
+                              <p:par>
+                                <p:cTn id="9" presetID="1" presetClass="entr" presetSubtype="0" fill="hold" grpId="0" nodeType="clickEffect">
+                                  <p:stCondLst>
+                                    <p:cond delay="0"/>
+                                  </p:stCondLst>
+                                  <p:childTnLst>
+                                    <p:set>
+                                      <p:cBhvr>
+                                        <p:cTn id="10" dur="1" fill="hold">
+                                          <p:stCondLst>
+                                            <p:cond delay="0"/>
+                                          </p:stCondLst>
+                                        </p:cTn>
+                                        <p:tgtEl>
+                                          <p:spTgt spid="3">
+                                            <p:txEl>
+                                              <p:pRg st="1" end="1"/>
+                                            </p:txEl>
+                                          </p:spTgt>
+                                        </p:tgtEl>
+                                        <p:attrNameLst>
+                                          <p:attrName>style.visibility</p:attrName>
+                                        </p:attrNameLst>
+                                      </p:cBhvr>
+                                      <p:to>
+                                        <p:strVal val="visible"/>
+                                      </p:to>
+                                    </p:set>
+                                  </p:childTnLst>
+                                </p:cTn>
+                              </p:par>
+                            </p:childTnLst>
+                          </p:cTn>
+                        </p:par>
+                      </p:childTnLst>
+                    </p:cTn>
+                  </p:par>
+                  <p:par>
+                    <p:cTn id="11" fill="hold">
+                      <p:stCondLst>
+                        <p:cond delay="indefinite"/>
+                      </p:stCondLst>
+                      <p:childTnLst>
+                        <p:par>
+                          <p:cTn id="12" fill="hold">
+                            <p:stCondLst>
+                              <p:cond delay="0"/>
+                            </p:stCondLst>
+                            <p:childTnLst>
+                              <p:par>
+                                <p:cTn id="13" presetID="1" presetClass="entr" presetSubtype="0" fill="hold" grpId="0" nodeType="clickEffect">
+                                  <p:stCondLst>
+                                    <p:cond delay="0"/>
+                                  </p:stCondLst>
+                                  <p:childTnLst>
+                                    <p:set>
+                                      <p:cBhvr>
+                                        <p:cTn id="14" dur="1" fill="hold">
+                                          <p:stCondLst>
+                                            <p:cond delay="0"/>
+                                          </p:stCondLst>
+                                        </p:cTn>
+                                        <p:tgtEl>
+                                          <p:spTgt spid="3">
+                                            <p:txEl>
+                                              <p:pRg st="2" end="2"/>
+                                            </p:txEl>
+                                          </p:spTgt>
+                                        </p:tgtEl>
+                                        <p:attrNameLst>
+                                          <p:attrName>style.visibility</p:attrName>
+                                        </p:attrNameLst>
+                                      </p:cBhvr>
+                                      <p:to>
+                                        <p:strVal val="visible"/>
+                                      </p:to>
+                                    </p:set>
+                                  </p:childTnLst>
+                                </p:cTn>
+                              </p:par>
+                            </p:childTnLst>
+                          </p:cTn>
+                        </p:par>
+                      </p:childTnLst>
+                    </p:cTn>
+                  </p:par>
+                  <p:par>
+                    <p:cTn id="15" fill="hold">
+                      <p:stCondLst>
+                        <p:cond delay="indefinite"/>
+                      </p:stCondLst>
+                      <p:childTnLst>
+                        <p:par>
+                          <p:cTn id="16" fill="hold">
+                            <p:stCondLst>
+                              <p:cond delay="0"/>
+                            </p:stCondLst>
+                            <p:childTnLst>
+                              <p:par>
+                                <p:cTn id="17" presetID="1" presetClass="entr" presetSubtype="0" fill="hold" grpId="0" nodeType="clickEffect">
+                                  <p:stCondLst>
+                                    <p:cond delay="0"/>
+                                  </p:stCondLst>
+                                  <p:childTnLst>
+                                    <p:set>
+                                      <p:cBhvr>
+                                        <p:cTn id="18" dur="1" fill="hold">
+                                          <p:stCondLst>
+                                            <p:cond delay="0"/>
+                                          </p:stCondLst>
+                                        </p:cTn>
+                                        <p:tgtEl>
+                                          <p:spTgt spid="3">
+                                            <p:txEl>
+                                              <p:pRg st="3" end="3"/>
+                                            </p:txEl>
+                                          </p:spTgt>
+                                        </p:tgtEl>
+                                        <p:attrNameLst>
+                                          <p:attrName>style.visibility</p:attrName>
+                                        </p:attrNameLst>
+                                      </p:cBhvr>
+                                      <p:to>
+                                        <p:strVal val="visible"/>
+                                      </p:to>
+                                    </p:set>
+                                  </p:childTnLst>
+                                </p:cTn>
+                              </p:par>
+                            </p:childTnLst>
+                          </p:cTn>
+                        </p:par>
+                      </p:childTnLst>
+                    </p:cTn>
+                  </p:par>
+                  <p:par>
+                    <p:cTn id="19" fill="hold">
+                      <p:stCondLst>
+                        <p:cond delay="indefinite"/>
+                      </p:stCondLst>
+                      <p:childTnLst>
+                        <p:par>
+                          <p:cTn id="20" fill="hold">
+                            <p:stCondLst>
+                              <p:cond delay="0"/>
+                            </p:stCondLst>
+                            <p:childTnLst>
+                              <p:par>
+                                <p:cTn id="21" presetID="1" presetClass="entr" presetSubtype="0" fill="hold" grpId="0" nodeType="clickEffect">
+                                  <p:stCondLst>
+                                    <p:cond delay="0"/>
+                                  </p:stCondLst>
+                                  <p:childTnLst>
+                                    <p:set>
+                                      <p:cBhvr>
+                                        <p:cTn id="22" dur="1" fill="hold">
+                                          <p:stCondLst>
+                                            <p:cond delay="0"/>
+                                          </p:stCondLst>
+                                        </p:cTn>
+                                        <p:tgtEl>
+                                          <p:spTgt spid="3">
+                                            <p:txEl>
+                                              <p:pRg st="4" end="4"/>
+                                            </p:txEl>
+                                          </p:spTgt>
+                                        </p:tgtEl>
+                                        <p:attrNameLst>
+                                          <p:attrName>style.visibility</p:attrName>
+                                        </p:attrNameLst>
+                                      </p:cBhvr>
+                                      <p:to>
+                                        <p:strVal val="visible"/>
+                                      </p:to>
+                                    </p:set>
+                                  </p:childTnLst>
+                                </p:cTn>
+                              </p:par>
+                            </p:childTnLst>
+                          </p:cTn>
+                        </p:par>
+                      </p:childTnLst>
+                    </p:cTn>
+                  </p:par>
+                  <p:par>
+                    <p:cTn id="23" fill="hold">
+                      <p:stCondLst>
+                        <p:cond delay="indefinite"/>
+                      </p:stCondLst>
+                      <p:childTnLst>
+                        <p:par>
+                          <p:cTn id="24" fill="hold">
+                            <p:stCondLst>
+                              <p:cond delay="0"/>
+                            </p:stCondLst>
+                            <p:childTnLst>
+                              <p:par>
+                                <p:cTn id="25" presetID="1" presetClass="entr" presetSubtype="0" fill="hold" grpId="0" nodeType="clickEffect">
+                                  <p:stCondLst>
+                                    <p:cond delay="0"/>
+                                  </p:stCondLst>
+                                  <p:childTnLst>
+                                    <p:set>
+                                      <p:cBhvr>
+                                        <p:cTn id="26" dur="1" fill="hold">
+                                          <p:stCondLst>
+                                            <p:cond delay="0"/>
+                                          </p:stCondLst>
+                                        </p:cTn>
+                                        <p:tgtEl>
+                                          <p:spTgt spid="3">
+                                            <p:txEl>
+                                              <p:pRg st="5" end="5"/>
+                                            </p:txEl>
+                                          </p:spTgt>
+                                        </p:tgtEl>
+                                        <p:attrNameLst>
+                                          <p:attrName>style.visibility</p:attrName>
+                                        </p:attrNameLst>
+                                      </p:cBhvr>
+                                      <p:to>
+                                        <p:strVal val="visible"/>
+                                      </p:to>
+                                    </p:set>
+                                  </p:childTnLst>
+                                </p:cTn>
+                              </p:par>
+                            </p:childTnLst>
+                          </p:cTn>
+                        </p:par>
+                      </p:childTnLst>
+                    </p:cTn>
+                  </p:par>
+                  <p:par>
+                    <p:cTn id="27" fill="hold">
+                      <p:stCondLst>
+                        <p:cond delay="indefinite"/>
+                      </p:stCondLst>
+                      <p:childTnLst>
+                        <p:par>
+                          <p:cTn id="28" fill="hold">
+                            <p:stCondLst>
+                              <p:cond delay="0"/>
+                            </p:stCondLst>
+                            <p:childTnLst>
+                              <p:par>
+                                <p:cTn id="29" presetID="1" presetClass="entr" presetSubtype="0" fill="hold" grpId="0" nodeType="clickEffect">
+                                  <p:stCondLst>
+                                    <p:cond delay="0"/>
+                                  </p:stCondLst>
+                                  <p:childTnLst>
+                                    <p:set>
+                                      <p:cBhvr>
+                                        <p:cTn id="30" dur="1" fill="hold">
+                                          <p:stCondLst>
+                                            <p:cond delay="0"/>
+                                          </p:stCondLst>
+                                        </p:cTn>
+                                        <p:tgtEl>
+                                          <p:spTgt spid="3">
+                                            <p:txEl>
+                                              <p:pRg st="6" end="6"/>
+                                            </p:txEl>
+                                          </p:spTgt>
+                                        </p:tgtEl>
+                                        <p:attrNameLst>
+                                          <p:attrName>style.visibility</p:attrName>
+                                        </p:attrNameLst>
+                                      </p:cBhvr>
+                                      <p:to>
+                                        <p:strVal val="visible"/>
+                                      </p:to>
+                                    </p:set>
+                                  </p:childTnLst>
+                                </p:cTn>
+                              </p:par>
+                            </p:childTnLst>
+                          </p:cTn>
+                        </p:par>
+                      </p:childTnLst>
+                    </p:cTn>
+                  </p:par>
+                  <p:par>
+                    <p:cTn id="31" fill="hold">
+                      <p:stCondLst>
+                        <p:cond delay="indefinite"/>
+                      </p:stCondLst>
+                      <p:childTnLst>
+                        <p:par>
+                          <p:cTn id="32" fill="hold">
+                            <p:stCondLst>
+                              <p:cond delay="0"/>
+                            </p:stCondLst>
+                            <p:childTnLst>
+                              <p:par>
+                                <p:cTn id="33" presetID="1" presetClass="entr" presetSubtype="0" fill="hold" grpId="0" nodeType="clickEffect">
+                                  <p:stCondLst>
+                                    <p:cond delay="0"/>
+                                  </p:stCondLst>
+                                  <p:childTnLst>
+                                    <p:set>
+                                      <p:cBhvr>
+                                        <p:cTn id="34" dur="1" fill="hold">
+                                          <p:stCondLst>
+                                            <p:cond delay="0"/>
+                                          </p:stCondLst>
+                                        </p:cTn>
+                                        <p:tgtEl>
+                                          <p:spTgt spid="3">
+                                            <p:txEl>
+                                              <p:pRg st="7" end="7"/>
+                                            </p:txEl>
+                                          </p:spTgt>
+                                        </p:tgtEl>
+                                        <p:attrNameLst>
+                                          <p:attrName>style.visibility</p:attrName>
+                                        </p:attrNameLst>
+                                      </p:cBhvr>
+                                      <p:to>
+                                        <p:strVal val="visible"/>
+                                      </p:to>
+                                    </p:set>
+                                  </p:childTnLst>
+                                </p:cTn>
+                              </p:par>
+                            </p:childTnLst>
+                          </p:cTn>
+                        </p:par>
+                      </p:childTnLst>
+                    </p:cTn>
+                  </p:par>
+                  <p:par>
+                    <p:cTn id="35" fill="hold">
+                      <p:stCondLst>
+                        <p:cond delay="indefinite"/>
+                      </p:stCondLst>
+                      <p:childTnLst>
+                        <p:par>
+                          <p:cTn id="36" fill="hold">
+                            <p:stCondLst>
+                              <p:cond delay="0"/>
+                            </p:stCondLst>
+                            <p:childTnLst>
+                              <p:par>
+                                <p:cTn id="37" presetID="1" presetClass="entr" presetSubtype="0" fill="hold" grpId="0" nodeType="clickEffect">
+                                  <p:stCondLst>
+                                    <p:cond delay="0"/>
+                                  </p:stCondLst>
+                                  <p:childTnLst>
+                                    <p:set>
+                                      <p:cBhvr>
+                                        <p:cTn id="38" dur="1" fill="hold">
+                                          <p:stCondLst>
+                                            <p:cond delay="0"/>
+                                          </p:stCondLst>
+                                        </p:cTn>
+                                        <p:tgtEl>
+                                          <p:spTgt spid="3">
+                                            <p:txEl>
+                                              <p:pRg st="8" end="8"/>
+                                            </p:txEl>
+                                          </p:spTgt>
+                                        </p:tgtEl>
+                                        <p:attrNameLst>
+                                          <p:attrName>style.visibility</p:attrName>
+                                        </p:attrNameLst>
+                                      </p:cBhvr>
+                                      <p:to>
+                                        <p:strVal val="visible"/>
+                                      </p:to>
+                                    </p:set>
+                                  </p:childTnLst>
+                                </p:cTn>
+                              </p:par>
+                            </p:childTnLst>
+                          </p:cTn>
+                        </p:par>
+                      </p:childTnLst>
+                    </p:cTn>
+                  </p:par>
+                </p:childTnLst>
+              </p:cTn>
+              <p:prevCondLst>
+                <p:cond evt="onPrev" delay="0">
+                  <p:tgtEl>
+                    <p:sldTgt/>
+                  </p:tgtEl>
+                </p:cond>
+              </p:prevCondLst>
+              <p:nextCondLst>
+                <p:cond evt="onNext" delay="0">
+                  <p:tgtEl>
+                    <p:sldTgt/>
+                  </p:tgtEl>
+                </p:cond>
+              </p:nextCondLst>
+            </p:seq>
+          </p:childTnLst>
+        </p:cTn>
+      </p:par>
+    </p:tnLst>
+    <p:bldLst>
+      <p:bldP spid="3" grpId="0" build="p"/>
+      <p:bldP spid="3" grpId="1" build="p"/>
+    </p:bldLst>
+  </p:timing>
 </p:sld>
 </file>
 
@@ -4720,7 +5204,6 @@
   <p:tag name="KSO_WM_UNIT_ID" val="_2**"/>
   <p:tag name="KSO_WM_UNIT_LAYERLEVEL" val="1"/>
   <p:tag name="KSO_WM_TAG_VERSION" val="1.0"/>
-  <p:tag name="KSO_WM_BEAUTIFY_FLAG" val="#wm#"/>
 </p:tagLst>
 </file>
 

</xml_diff>